<commit_message>
Next draft on Lake Mead Program
</commit_message>
<xml_diff>
--- a/LakeMeadWaterConservationProgramAnalysis/FixAnnualCredits.pptx
+++ b/LakeMeadWaterConservationProgramAnalysis/FixAnnualCredits.pptx
@@ -259,7 +259,7 @@
           <a:p>
             <a:fld id="{68A6762C-DC55-4D65-AC8B-F990ED8BD500}" type="datetimeFigureOut">
               <a:rPr lang="en-US" smtClean="0"/>
-              <a:t>5/22/2026</a:t>
+              <a:t>7/9/2026</a:t>
             </a:fld>
             <a:endParaRPr lang="en-US"/>
           </a:p>
@@ -457,7 +457,7 @@
           <a:p>
             <a:fld id="{68A6762C-DC55-4D65-AC8B-F990ED8BD500}" type="datetimeFigureOut">
               <a:rPr lang="en-US" smtClean="0"/>
-              <a:t>5/22/2026</a:t>
+              <a:t>7/9/2026</a:t>
             </a:fld>
             <a:endParaRPr lang="en-US"/>
           </a:p>
@@ -665,7 +665,7 @@
           <a:p>
             <a:fld id="{68A6762C-DC55-4D65-AC8B-F990ED8BD500}" type="datetimeFigureOut">
               <a:rPr lang="en-US" smtClean="0"/>
-              <a:t>5/22/2026</a:t>
+              <a:t>7/9/2026</a:t>
             </a:fld>
             <a:endParaRPr lang="en-US"/>
           </a:p>
@@ -863,7 +863,7 @@
           <a:p>
             <a:fld id="{68A6762C-DC55-4D65-AC8B-F990ED8BD500}" type="datetimeFigureOut">
               <a:rPr lang="en-US" smtClean="0"/>
-              <a:t>5/22/2026</a:t>
+              <a:t>7/9/2026</a:t>
             </a:fld>
             <a:endParaRPr lang="en-US"/>
           </a:p>
@@ -1138,7 +1138,7 @@
           <a:p>
             <a:fld id="{68A6762C-DC55-4D65-AC8B-F990ED8BD500}" type="datetimeFigureOut">
               <a:rPr lang="en-US" smtClean="0"/>
-              <a:t>5/22/2026</a:t>
+              <a:t>7/9/2026</a:t>
             </a:fld>
             <a:endParaRPr lang="en-US"/>
           </a:p>
@@ -1403,7 +1403,7 @@
           <a:p>
             <a:fld id="{68A6762C-DC55-4D65-AC8B-F990ED8BD500}" type="datetimeFigureOut">
               <a:rPr lang="en-US" smtClean="0"/>
-              <a:t>5/22/2026</a:t>
+              <a:t>7/9/2026</a:t>
             </a:fld>
             <a:endParaRPr lang="en-US"/>
           </a:p>
@@ -1815,7 +1815,7 @@
           <a:p>
             <a:fld id="{68A6762C-DC55-4D65-AC8B-F990ED8BD500}" type="datetimeFigureOut">
               <a:rPr lang="en-US" smtClean="0"/>
-              <a:t>5/22/2026</a:t>
+              <a:t>7/9/2026</a:t>
             </a:fld>
             <a:endParaRPr lang="en-US"/>
           </a:p>
@@ -1956,7 +1956,7 @@
           <a:p>
             <a:fld id="{68A6762C-DC55-4D65-AC8B-F990ED8BD500}" type="datetimeFigureOut">
               <a:rPr lang="en-US" smtClean="0"/>
-              <a:t>5/22/2026</a:t>
+              <a:t>7/9/2026</a:t>
             </a:fld>
             <a:endParaRPr lang="en-US"/>
           </a:p>
@@ -2069,7 +2069,7 @@
           <a:p>
             <a:fld id="{68A6762C-DC55-4D65-AC8B-F990ED8BD500}" type="datetimeFigureOut">
               <a:rPr lang="en-US" smtClean="0"/>
-              <a:t>5/22/2026</a:t>
+              <a:t>7/9/2026</a:t>
             </a:fld>
             <a:endParaRPr lang="en-US"/>
           </a:p>
@@ -2380,7 +2380,7 @@
           <a:p>
             <a:fld id="{68A6762C-DC55-4D65-AC8B-F990ED8BD500}" type="datetimeFigureOut">
               <a:rPr lang="en-US" smtClean="0"/>
-              <a:t>5/22/2026</a:t>
+              <a:t>7/9/2026</a:t>
             </a:fld>
             <a:endParaRPr lang="en-US"/>
           </a:p>
@@ -2668,7 +2668,7 @@
           <a:p>
             <a:fld id="{68A6762C-DC55-4D65-AC8B-F990ED8BD500}" type="datetimeFigureOut">
               <a:rPr lang="en-US" smtClean="0"/>
-              <a:t>5/22/2026</a:t>
+              <a:t>7/9/2026</a:t>
             </a:fld>
             <a:endParaRPr lang="en-US"/>
           </a:p>
@@ -2909,7 +2909,7 @@
           <a:p>
             <a:fld id="{68A6762C-DC55-4D65-AC8B-F990ED8BD500}" type="datetimeFigureOut">
               <a:rPr lang="en-US" smtClean="0"/>
-              <a:t>5/22/2026</a:t>
+              <a:t>7/9/2026</a:t>
             </a:fld>
             <a:endParaRPr lang="en-US"/>
           </a:p>
@@ -3652,7 +3652,7 @@
                     </a:schemeClr>
                   </a:solidFill>
                 </a:rPr>
-                <a:t>C</a:t>
+                <a:t>M</a:t>
               </a:r>
               <a:r>
                 <a:rPr lang="en-US" sz="2000" b="1" baseline="-25000" dirty="0" err="1">
@@ -4036,7 +4036,7 @@
                     </a:schemeClr>
                   </a:solidFill>
                 </a:rPr>
-                <a:t>C</a:t>
+                <a:t>M</a:t>
               </a:r>
               <a:r>
                 <a:rPr lang="en-US" sz="2400" b="1" baseline="-25000" dirty="0" err="1">
@@ -4046,7 +4046,7 @@
                     </a:schemeClr>
                   </a:solidFill>
                 </a:rPr>
-                <a:t>total</a:t>
+                <a:t>Total</a:t>
               </a:r>
               <a:endParaRPr lang="en-US" sz="2400" b="1" baseline="-25000" dirty="0">
                 <a:solidFill>
@@ -4178,7 +4178,7 @@
                     </a:schemeClr>
                   </a:solidFill>
                 </a:rPr>
-                <a:t>C</a:t>
+                <a:t>M</a:t>
               </a:r>
               <a:r>
                 <a:rPr lang="en-US" sz="2400" b="1" baseline="-25000" dirty="0" err="1">
@@ -4188,7 +4188,7 @@
                     </a:schemeClr>
                   </a:solidFill>
                 </a:rPr>
-                <a:t>total</a:t>
+                <a:t>Total</a:t>
               </a:r>
               <a:r>
                 <a:rPr lang="en-US" sz="2400" b="1" dirty="0">
@@ -4449,7 +4449,7 @@
                     </a:schemeClr>
                   </a:solidFill>
                 </a:rPr>
-                <a:t>C</a:t>
+                <a:t>M</a:t>
               </a:r>
               <a:r>
                 <a:rPr lang="en-US" sz="2000" b="1" baseline="-25000" dirty="0" err="1">
@@ -4768,7 +4768,7 @@
                     </a:schemeClr>
                   </a:solidFill>
                 </a:rPr>
-                <a:t>C</a:t>
+                <a:t>M</a:t>
               </a:r>
               <a:r>
                 <a:rPr lang="en-US" sz="2400" b="1" baseline="-25000" dirty="0" err="1">
@@ -4778,7 +4778,7 @@
                     </a:schemeClr>
                   </a:solidFill>
                 </a:rPr>
-                <a:t>total</a:t>
+                <a:t>Total</a:t>
               </a:r>
               <a:endParaRPr lang="en-US" sz="2400" b="1" baseline="-25000" dirty="0">
                 <a:solidFill>
@@ -4900,7 +4900,7 @@
                     <a:srgbClr val="7030A0"/>
                   </a:solidFill>
                 </a:rPr>
-                <a:t>total</a:t>
+                <a:t>Total</a:t>
               </a:r>
               <a:r>
                 <a:rPr lang="en-US" sz="2400" b="1" baseline="-25000" dirty="0">
@@ -4928,7 +4928,7 @@
                     <a:srgbClr val="0000FF"/>
                   </a:solidFill>
                 </a:rPr>
-                <a:t>physical</a:t>
+                <a:t>Physical</a:t>
               </a:r>
               <a:endParaRPr lang="en-US" sz="2400" b="1" dirty="0"/>
             </a:p>
@@ -4976,7 +4976,7 @@
                     <a:srgbClr val="0000FF"/>
                   </a:solidFill>
                 </a:rPr>
-                <a:t>physical</a:t>
+                <a:t>Physical</a:t>
               </a:r>
               <a:r>
                 <a:rPr lang="en-US" sz="2400" b="1" baseline="-25000" dirty="0">
@@ -5008,7 +5008,7 @@
                     <a:srgbClr val="7030A0"/>
                   </a:solidFill>
                 </a:rPr>
-                <a:t>total</a:t>
+                <a:t>Total</a:t>
               </a:r>
               <a:r>
                 <a:rPr lang="en-US" sz="2400" b="1" dirty="0"/>

</xml_diff>